<commit_message>
Rebuild PPTX + PDF deck from deck.html with theFinlyApp branding + updated scores
- Captured 3 slides at 1920x1080 via Playwright
- Built PPTX with full-bleed slide images (Keynote-compatible)
- Exported PDF via Keynote AppleScript
- Scores: Fidelity 87.8, Privacy 100, Utility 92.7
- All slides show theFinlyApp branding
</commit_message>
<xml_diff>
--- a/pitch/Southlake-Agentic-Synthetic-Data-Studio-Deck.pptx
+++ b/pitch/Southlake-Agentic-Synthetic-Data-Studio-Deck.pptx
@@ -9,7 +9,7 @@
     <p:sldId id="257" r:id="rId8"/>
     <p:sldId id="258" r:id="rId9"/>
   </p:sldIdLst>
-  <p:sldSz cx="12191695" cy="6858000" type="screen4x3"/>
+  <p:sldSz cx="12192000" cy="6858000" type="screen4x3"/>
   <p:notesSz cx="6858000" cy="9144000"/>
   <p:defaultTextStyle>
     <a:defPPr>
@@ -3083,14 +3083,6 @@
 <file path=ppt/slides/slide1.xml><?xml version="1.0" encoding="utf-8"?>
 <p:sld xmlns:a="http://schemas.openxmlformats.org/drawingml/2006/main" xmlns:p="http://schemas.openxmlformats.org/presentationml/2006/main" xmlns:r="http://schemas.openxmlformats.org/officeDocument/2006/relationships">
   <p:cSld>
-    <p:bg>
-      <p:bgPr>
-        <a:solidFill>
-          <a:srgbClr val="F4F7F4"/>
-        </a:solidFill>
-        <a:effectLst/>
-      </p:bgPr>
-    </p:bg>
     <p:spTree>
       <p:nvGrpSpPr>
         <p:cNvPr id="1" name=""/>
@@ -3098,658 +3090,9 @@
         <p:nvPr/>
       </p:nvGrpSpPr>
       <p:grpSpPr/>
-      <p:sp>
-        <p:nvSpPr>
-          <p:cNvPr id="2" name="Oval 1"/>
-          <p:cNvSpPr/>
-          <p:nvPr/>
-        </p:nvSpPr>
-        <p:spPr>
-          <a:xfrm>
-            <a:off x="-411480" y="-502920"/>
-            <a:ext cx="2651760" cy="2651760"/>
-          </a:xfrm>
-          <a:prstGeom prst="ellipse">
-            <a:avLst/>
-          </a:prstGeom>
-          <a:solidFill>
-            <a:srgbClr val="DFF8EC"/>
-          </a:solidFill>
-          <a:ln>
-            <a:noFill/>
-          </a:ln>
-        </p:spPr>
-        <p:style>
-          <a:lnRef idx="1">
-            <a:schemeClr val="accent1"/>
-          </a:lnRef>
-          <a:fillRef idx="3">
-            <a:schemeClr val="accent1"/>
-          </a:fillRef>
-          <a:effectRef idx="2">
-            <a:schemeClr val="accent1"/>
-          </a:effectRef>
-          <a:fontRef idx="minor">
-            <a:schemeClr val="lt1"/>
-          </a:fontRef>
-        </p:style>
-        <p:txBody>
-          <a:bodyPr rtlCol="0" anchor="ctr"/>
-          <a:lstStyle/>
-          <a:p>
-            <a:pPr algn="ctr"/>
-          </a:p>
-        </p:txBody>
-      </p:sp>
-      <p:sp>
-        <p:nvSpPr>
-          <p:cNvPr id="3" name="Oval 2"/>
-          <p:cNvSpPr/>
-          <p:nvPr/>
-        </p:nvSpPr>
-        <p:spPr>
-          <a:xfrm>
-            <a:off x="10241280" y="-365760"/>
-            <a:ext cx="1920240" cy="1920240"/>
-          </a:xfrm>
-          <a:prstGeom prst="ellipse">
-            <a:avLst/>
-          </a:prstGeom>
-          <a:solidFill>
-            <a:srgbClr val="F2E7CF"/>
-          </a:solidFill>
-          <a:ln>
-            <a:noFill/>
-          </a:ln>
-        </p:spPr>
-        <p:style>
-          <a:lnRef idx="1">
-            <a:schemeClr val="accent1"/>
-          </a:lnRef>
-          <a:fillRef idx="3">
-            <a:schemeClr val="accent1"/>
-          </a:fillRef>
-          <a:effectRef idx="2">
-            <a:schemeClr val="accent1"/>
-          </a:effectRef>
-          <a:fontRef idx="minor">
-            <a:schemeClr val="lt1"/>
-          </a:fontRef>
-        </p:style>
-        <p:txBody>
-          <a:bodyPr rtlCol="0" anchor="ctr"/>
-          <a:lstStyle/>
-          <a:p>
-            <a:pPr algn="ctr"/>
-          </a:p>
-        </p:txBody>
-      </p:sp>
-      <p:sp>
-        <p:nvSpPr>
-          <p:cNvPr id="4" name="TextBox 3"/>
-          <p:cNvSpPr txBox="1"/>
-          <p:nvPr/>
-        </p:nvSpPr>
-        <p:spPr>
-          <a:xfrm>
-            <a:off x="658368" y="384048"/>
-            <a:ext cx="4572000" cy="320040"/>
-          </a:xfrm>
-          <a:prstGeom prst="rect">
-            <a:avLst/>
-          </a:prstGeom>
-          <a:noFill/>
-        </p:spPr>
-        <p:txBody>
-          <a:bodyPr wrap="square" anchor="t">
-            <a:spAutoFit/>
-          </a:bodyPr>
-          <a:lstStyle/>
-          <a:p>
-            <a:pPr algn="l"/>
-            <a:r>
-              <a:rPr sz="1100" b="1">
-                <a:solidFill>
-                  <a:srgbClr val="0F7C82"/>
-                </a:solidFill>
-                <a:latin typeface="Aptos"/>
-              </a:rPr>
-              <a:t>METHODOLOGY</a:t>
-            </a:r>
-          </a:p>
-        </p:txBody>
-      </p:sp>
-      <p:sp>
-        <p:nvSpPr>
-          <p:cNvPr id="5" name="TextBox 4"/>
-          <p:cNvSpPr txBox="1"/>
-          <p:nvPr/>
-        </p:nvSpPr>
-        <p:spPr>
-          <a:xfrm>
-            <a:off x="658368" y="658368"/>
-            <a:ext cx="8046720" cy="1115568"/>
-          </a:xfrm>
-          <a:prstGeom prst="rect">
-            <a:avLst/>
-          </a:prstGeom>
-          <a:noFill/>
-        </p:spPr>
-        <p:txBody>
-          <a:bodyPr wrap="square" anchor="t">
-            <a:spAutoFit/>
-          </a:bodyPr>
-          <a:lstStyle/>
-          <a:p>
-            <a:pPr algn="l"/>
-            <a:r>
-              <a:rPr sz="2400" b="1">
-                <a:solidFill>
-                  <a:srgbClr val="102A43"/>
-                </a:solidFill>
-                <a:latin typeface="Aptos Display"/>
-              </a:rPr>
-              <a:t>From Public ED Data To Southlake Future-State Planning Scenarios</a:t>
-            </a:r>
-          </a:p>
-        </p:txBody>
-      </p:sp>
-      <p:sp>
-        <p:nvSpPr>
-          <p:cNvPr id="6" name="TextBox 5"/>
-          <p:cNvSpPr txBox="1"/>
-          <p:nvPr/>
-        </p:nvSpPr>
-        <p:spPr>
-          <a:xfrm>
-            <a:off x="658368" y="1645920"/>
-            <a:ext cx="8138160" cy="274320"/>
-          </a:xfrm>
-          <a:prstGeom prst="rect">
-            <a:avLst/>
-          </a:prstGeom>
-          <a:noFill/>
-        </p:spPr>
-        <p:txBody>
-          <a:bodyPr wrap="square" anchor="t">
-            <a:spAutoFit/>
-          </a:bodyPr>
-          <a:lstStyle/>
-          <a:p>
-            <a:pPr algn="l"/>
-            <a:r>
-              <a:rPr sz="1300" b="0">
-                <a:solidFill>
-                  <a:srgbClr val="5A7184"/>
-                </a:solidFill>
-                <a:latin typeface="Aptos"/>
-              </a:rPr>
-              <a:t>Agentic synthetic data workflow for distributed-health-network planning questions.</a:t>
-            </a:r>
-          </a:p>
-        </p:txBody>
-      </p:sp>
-      <p:sp>
-        <p:nvSpPr>
-          <p:cNvPr id="7" name="Rounded Rectangle 6"/>
-          <p:cNvSpPr/>
-          <p:nvPr/>
-        </p:nvSpPr>
-        <p:spPr>
-          <a:xfrm>
-            <a:off x="10789920" y="384048"/>
-            <a:ext cx="731520" cy="347472"/>
-          </a:xfrm>
-          <a:prstGeom prst="roundRect">
-            <a:avLst/>
-          </a:prstGeom>
-          <a:solidFill>
-            <a:srgbClr val="FFFFFF"/>
-          </a:solidFill>
-          <a:ln w="12700">
-            <a:solidFill>
-              <a:srgbClr val="DCE3EA"/>
-            </a:solidFill>
-          </a:ln>
-        </p:spPr>
-        <p:style>
-          <a:lnRef idx="1">
-            <a:schemeClr val="accent1"/>
-          </a:lnRef>
-          <a:fillRef idx="3">
-            <a:schemeClr val="accent1"/>
-          </a:fillRef>
-          <a:effectRef idx="2">
-            <a:schemeClr val="accent1"/>
-          </a:effectRef>
-          <a:fontRef idx="minor">
-            <a:schemeClr val="lt1"/>
-          </a:fontRef>
-        </p:style>
-        <p:txBody>
-          <a:bodyPr rtlCol="0" anchor="ctr"/>
-          <a:lstStyle/>
-          <a:p>
-            <a:pPr algn="ctr"/>
-            <a:r>
-              <a:rPr sz="1100" b="1">
-                <a:solidFill>
-                  <a:srgbClr val="5A7184"/>
-                </a:solidFill>
-                <a:latin typeface="Aptos"/>
-              </a:rPr>
-              <a:t>1/3</a:t>
-            </a:r>
-          </a:p>
-        </p:txBody>
-      </p:sp>
-      <p:sp>
-        <p:nvSpPr>
-          <p:cNvPr id="8" name="Rounded Rectangle 7"/>
-          <p:cNvSpPr/>
-          <p:nvPr/>
-        </p:nvSpPr>
-        <p:spPr>
-          <a:xfrm>
-            <a:off x="566928" y="1993392"/>
-            <a:ext cx="4160520" cy="1536192"/>
-          </a:xfrm>
-          <a:prstGeom prst="roundRect">
-            <a:avLst/>
-          </a:prstGeom>
-          <a:solidFill>
-            <a:srgbClr val="FFFFFF"/>
-          </a:solidFill>
-          <a:ln w="12700">
-            <a:solidFill>
-              <a:srgbClr val="E4E9ED"/>
-            </a:solidFill>
-          </a:ln>
-        </p:spPr>
-        <p:style>
-          <a:lnRef idx="1">
-            <a:schemeClr val="accent1"/>
-          </a:lnRef>
-          <a:fillRef idx="3">
-            <a:schemeClr val="accent1"/>
-          </a:fillRef>
-          <a:effectRef idx="2">
-            <a:schemeClr val="accent1"/>
-          </a:effectRef>
-          <a:fontRef idx="minor">
-            <a:schemeClr val="lt1"/>
-          </a:fontRef>
-        </p:style>
-        <p:txBody>
-          <a:bodyPr rtlCol="0" anchor="ctr" wrap="square"/>
-          <a:lstStyle/>
-          <a:p>
-            <a:pPr algn="ctr"/>
-            <a:r>
-              <a:rPr sz="1100" b="1">
-                <a:solidFill>
-                  <a:srgbClr val="0F7C82"/>
-                </a:solidFill>
-                <a:latin typeface="Aptos"/>
-              </a:rPr>
-              <a:t>Core Message</a:t>
-            </a:r>
-          </a:p>
-          <a:p>
-            <a:pPr>
-              <a:spcAft>
-                <a:spcPts val="1200"/>
-              </a:spcAft>
-              <a:defRPr sz="1700" b="1">
-                <a:solidFill>
-                  <a:srgbClr val="102A43"/>
-                </a:solidFill>
-                <a:latin typeface="Aptos"/>
-              </a:defRPr>
-            </a:pPr>
-            <a:r>
-              <a:t>We turn safe public ED data into synthetic planning artifacts for Southlake's distributed-health-network questions, then make the limitations visible before anyone over-trusts the output.</a:t>
-            </a:r>
-          </a:p>
-        </p:txBody>
-      </p:sp>
-      <p:sp>
-        <p:nvSpPr>
-          <p:cNvPr id="9" name="Rounded Rectangle 8"/>
-          <p:cNvSpPr/>
-          <p:nvPr/>
-        </p:nvSpPr>
-        <p:spPr>
-          <a:xfrm>
-            <a:off x="566928" y="3712463"/>
-            <a:ext cx="2029968" cy="1170432"/>
-          </a:xfrm>
-          <a:prstGeom prst="roundRect">
-            <a:avLst/>
-          </a:prstGeom>
-          <a:solidFill>
-            <a:srgbClr val="DFF8EC"/>
-          </a:solidFill>
-          <a:ln>
-            <a:noFill/>
-          </a:ln>
-        </p:spPr>
-        <p:style>
-          <a:lnRef idx="1">
-            <a:schemeClr val="accent1"/>
-          </a:lnRef>
-          <a:fillRef idx="3">
-            <a:schemeClr val="accent1"/>
-          </a:fillRef>
-          <a:effectRef idx="2">
-            <a:schemeClr val="accent1"/>
-          </a:effectRef>
-          <a:fontRef idx="minor">
-            <a:schemeClr val="lt1"/>
-          </a:fontRef>
-        </p:style>
-        <p:txBody>
-          <a:bodyPr rtlCol="0" anchor="ctr" wrap="square"/>
-          <a:lstStyle/>
-          <a:p>
-            <a:pPr algn="ctr"/>
-            <a:r>
-              <a:rPr sz="1200" b="1">
-                <a:solidFill>
-                  <a:srgbClr val="096149"/>
-                </a:solidFill>
-                <a:latin typeface="Aptos"/>
-              </a:rPr>
-              <a:t>Input</a:t>
-            </a:r>
-          </a:p>
-          <a:p>
-            <a:pPr>
-              <a:spcBef>
-                <a:spcPts val="300"/>
-              </a:spcBef>
-              <a:spcAft>
-                <a:spcPts val="0"/>
-              </a:spcAft>
-              <a:defRPr sz="1100">
-                <a:solidFill>
-                  <a:srgbClr val="102A43"/>
-                </a:solidFill>
-                <a:latin typeface="Aptos"/>
-              </a:defRPr>
-            </a:pPr>
-            <a:r>
-              <a:t>Curated public ED dataset used as a safe planning stand-in.</a:t>
-            </a:r>
-          </a:p>
-        </p:txBody>
-      </p:sp>
-      <p:sp>
-        <p:nvSpPr>
-          <p:cNvPr id="10" name="Rounded Rectangle 9"/>
-          <p:cNvSpPr/>
-          <p:nvPr/>
-        </p:nvSpPr>
-        <p:spPr>
-          <a:xfrm>
-            <a:off x="2697480" y="3712463"/>
-            <a:ext cx="2029968" cy="1170432"/>
-          </a:xfrm>
-          <a:prstGeom prst="roundRect">
-            <a:avLst/>
-          </a:prstGeom>
-          <a:solidFill>
-            <a:srgbClr val="FFFFFF"/>
-          </a:solidFill>
-          <a:ln w="12700">
-            <a:solidFill>
-              <a:srgbClr val="E4E9ED"/>
-            </a:solidFill>
-          </a:ln>
-        </p:spPr>
-        <p:style>
-          <a:lnRef idx="1">
-            <a:schemeClr val="accent1"/>
-          </a:lnRef>
-          <a:fillRef idx="3">
-            <a:schemeClr val="accent1"/>
-          </a:fillRef>
-          <a:effectRef idx="2">
-            <a:schemeClr val="accent1"/>
-          </a:effectRef>
-          <a:fontRef idx="minor">
-            <a:schemeClr val="lt1"/>
-          </a:fontRef>
-        </p:style>
-        <p:txBody>
-          <a:bodyPr rtlCol="0" anchor="ctr" wrap="square"/>
-          <a:lstStyle/>
-          <a:p>
-            <a:pPr algn="ctr"/>
-            <a:r>
-              <a:rPr sz="1200" b="1">
-                <a:solidFill>
-                  <a:srgbClr val="102A43"/>
-                </a:solidFill>
-                <a:latin typeface="Aptos"/>
-              </a:rPr>
-              <a:t>Agent Flow</a:t>
-            </a:r>
-          </a:p>
-          <a:p>
-            <a:pPr>
-              <a:spcBef>
-                <a:spcPts val="300"/>
-              </a:spcBef>
-              <a:spcAft>
-                <a:spcPts val="0"/>
-              </a:spcAft>
-              <a:defRPr sz="1100">
-                <a:solidFill>
-                  <a:srgbClr val="102A43"/>
-                </a:solidFill>
-                <a:latin typeface="Aptos"/>
-              </a:defRPr>
-            </a:pPr>
-            <a:r>
-              <a:t>Goal framing -&gt; profile -&gt; plan -&gt; generate -&gt; evaluate -&gt; caution report.</a:t>
-            </a:r>
-          </a:p>
-        </p:txBody>
-      </p:sp>
-      <p:sp>
-        <p:nvSpPr>
-          <p:cNvPr id="11" name="Rounded Rectangle 10"/>
-          <p:cNvSpPr/>
-          <p:nvPr/>
-        </p:nvSpPr>
-        <p:spPr>
-          <a:xfrm>
-            <a:off x="566928" y="5029200"/>
-            <a:ext cx="2029968" cy="1170432"/>
-          </a:xfrm>
-          <a:prstGeom prst="roundRect">
-            <a:avLst/>
-          </a:prstGeom>
-          <a:solidFill>
-            <a:srgbClr val="F2E7CF"/>
-          </a:solidFill>
-          <a:ln>
-            <a:noFill/>
-          </a:ln>
-        </p:spPr>
-        <p:style>
-          <a:lnRef idx="1">
-            <a:schemeClr val="accent1"/>
-          </a:lnRef>
-          <a:fillRef idx="3">
-            <a:schemeClr val="accent1"/>
-          </a:fillRef>
-          <a:effectRef idx="2">
-            <a:schemeClr val="accent1"/>
-          </a:effectRef>
-          <a:fontRef idx="minor">
-            <a:schemeClr val="lt1"/>
-          </a:fontRef>
-        </p:style>
-        <p:txBody>
-          <a:bodyPr rtlCol="0" anchor="ctr" wrap="square"/>
-          <a:lstStyle/>
-          <a:p>
-            <a:pPr algn="ctr"/>
-            <a:r>
-              <a:rPr sz="1200" b="1">
-                <a:solidFill>
-                  <a:srgbClr val="7A5200"/>
-                </a:solidFill>
-                <a:latin typeface="Aptos"/>
-              </a:rPr>
-              <a:t>Southlake Lens</a:t>
-            </a:r>
-          </a:p>
-          <a:p>
-            <a:pPr>
-              <a:spcBef>
-                <a:spcPts val="300"/>
-              </a:spcBef>
-              <a:spcAft>
-                <a:spcPts val="0"/>
-              </a:spcAft>
-              <a:defRPr sz="1100">
-                <a:solidFill>
-                  <a:srgbClr val="102A43"/>
-                </a:solidFill>
-                <a:latin typeface="Aptos"/>
-              </a:defRPr>
-            </a:pPr>
-            <a:r>
-              <a:t>Distributed campus routing, community diversion, growth, and surge scenarios.</a:t>
-            </a:r>
-          </a:p>
-        </p:txBody>
-      </p:sp>
-      <p:sp>
-        <p:nvSpPr>
-          <p:cNvPr id="12" name="Rounded Rectangle 11"/>
-          <p:cNvSpPr/>
-          <p:nvPr/>
-        </p:nvSpPr>
-        <p:spPr>
-          <a:xfrm>
-            <a:off x="2697480" y="5029200"/>
-            <a:ext cx="2029968" cy="1170432"/>
-          </a:xfrm>
-          <a:prstGeom prst="roundRect">
-            <a:avLst/>
-          </a:prstGeom>
-          <a:solidFill>
-            <a:srgbClr val="FFFFFF"/>
-          </a:solidFill>
-          <a:ln w="12700">
-            <a:solidFill>
-              <a:srgbClr val="E4E9ED"/>
-            </a:solidFill>
-          </a:ln>
-        </p:spPr>
-        <p:style>
-          <a:lnRef idx="1">
-            <a:schemeClr val="accent1"/>
-          </a:lnRef>
-          <a:fillRef idx="3">
-            <a:schemeClr val="accent1"/>
-          </a:fillRef>
-          <a:effectRef idx="2">
-            <a:schemeClr val="accent1"/>
-          </a:effectRef>
-          <a:fontRef idx="minor">
-            <a:schemeClr val="lt1"/>
-          </a:fontRef>
-        </p:style>
-        <p:txBody>
-          <a:bodyPr rtlCol="0" anchor="ctr" wrap="square"/>
-          <a:lstStyle/>
-          <a:p>
-            <a:pPr algn="ctr"/>
-            <a:r>
-              <a:rPr sz="1200" b="1">
-                <a:solidFill>
-                  <a:srgbClr val="102A43"/>
-                </a:solidFill>
-                <a:latin typeface="Aptos"/>
-              </a:rPr>
-              <a:t>Outputs</a:t>
-            </a:r>
-          </a:p>
-          <a:p>
-            <a:pPr>
-              <a:spcBef>
-                <a:spcPts val="300"/>
-              </a:spcBef>
-              <a:spcAft>
-                <a:spcPts val="0"/>
-              </a:spcAft>
-              <a:defRPr sz="1100">
-                <a:solidFill>
-                  <a:srgbClr val="102A43"/>
-                </a:solidFill>
-                <a:latin typeface="Aptos"/>
-              </a:defRPr>
-            </a:pPr>
-            <a:r>
-              <a:t>Synthetic dataset, metrics dashboard, caution summary, export ZIP, pitch artifacts.</a:t>
-            </a:r>
-          </a:p>
-        </p:txBody>
-      </p:sp>
-      <p:sp>
-        <p:nvSpPr>
-          <p:cNvPr id="13" name="Rounded Rectangle 12"/>
-          <p:cNvSpPr/>
-          <p:nvPr/>
-        </p:nvSpPr>
-        <p:spPr>
-          <a:xfrm>
-            <a:off x="5010912" y="1847088"/>
-            <a:ext cx="6629400" cy="4297680"/>
-          </a:xfrm>
-          <a:prstGeom prst="roundRect">
-            <a:avLst/>
-          </a:prstGeom>
-          <a:solidFill>
-            <a:srgbClr val="FFFFFF"/>
-          </a:solidFill>
-          <a:ln w="12700">
-            <a:solidFill>
-              <a:srgbClr val="E4E9ED"/>
-            </a:solidFill>
-          </a:ln>
-          <a:effectLst/>
-        </p:spPr>
-        <p:style>
-          <a:lnRef idx="1">
-            <a:schemeClr val="accent1"/>
-          </a:lnRef>
-          <a:fillRef idx="3">
-            <a:schemeClr val="accent1"/>
-          </a:fillRef>
-          <a:effectRef idx="2">
-            <a:schemeClr val="accent1"/>
-          </a:effectRef>
-          <a:fontRef idx="minor">
-            <a:schemeClr val="lt1"/>
-          </a:fontRef>
-        </p:style>
-        <p:txBody>
-          <a:bodyPr rtlCol="0" anchor="ctr"/>
-          <a:lstStyle/>
-          <a:p>
-            <a:pPr algn="ctr"/>
-          </a:p>
-        </p:txBody>
-      </p:sp>
       <p:pic>
         <p:nvPicPr>
-          <p:cNvPr id="14" name="Picture 13" descr="architecture-workflow.png"/>
+          <p:cNvPr id="2" name="Picture 1" descr="slide-1.png"/>
           <p:cNvPicPr>
             <a:picLocks noChangeAspect="1"/>
           </p:cNvPicPr>
@@ -3763,101 +3106,14 @@
         </p:blipFill>
         <p:spPr>
           <a:xfrm>
-            <a:off x="5230368" y="2066543"/>
-            <a:ext cx="6217920" cy="3493008"/>
+            <a:off x="0" y="0"/>
+            <a:ext cx="12192000" cy="6858000"/>
           </a:xfrm>
           <a:prstGeom prst="rect">
             <a:avLst/>
           </a:prstGeom>
         </p:spPr>
       </p:pic>
-      <p:sp>
-        <p:nvSpPr>
-          <p:cNvPr id="15" name="Rounded Rectangle 14"/>
-          <p:cNvSpPr/>
-          <p:nvPr/>
-        </p:nvSpPr>
-        <p:spPr>
-          <a:xfrm>
-            <a:off x="5010912" y="5687568"/>
-            <a:ext cx="6629400" cy="438912"/>
-          </a:xfrm>
-          <a:prstGeom prst="roundRect">
-            <a:avLst/>
-          </a:prstGeom>
-          <a:solidFill>
-            <a:srgbClr val="1E293B"/>
-          </a:solidFill>
-          <a:ln>
-            <a:noFill/>
-          </a:ln>
-        </p:spPr>
-        <p:style>
-          <a:lnRef idx="1">
-            <a:schemeClr val="accent1"/>
-          </a:lnRef>
-          <a:fillRef idx="3">
-            <a:schemeClr val="accent1"/>
-          </a:fillRef>
-          <a:effectRef idx="2">
-            <a:schemeClr val="accent1"/>
-          </a:effectRef>
-          <a:fontRef idx="minor">
-            <a:schemeClr val="lt1"/>
-          </a:fontRef>
-        </p:style>
-        <p:txBody>
-          <a:bodyPr rtlCol="0" anchor="ctr"/>
-          <a:lstStyle/>
-          <a:p>
-            <a:pPr algn="ctr"/>
-            <a:r>
-              <a:rPr sz="1300" b="1">
-                <a:solidFill>
-                  <a:srgbClr val="FFFFFF"/>
-                </a:solidFill>
-                <a:latin typeface="Aptos"/>
-              </a:rPr>
-              <a:t>Planning questions: campus routing | observation demand | transfer pathways | closer-to-home care</a:t>
-            </a:r>
-          </a:p>
-        </p:txBody>
-      </p:sp>
-      <p:sp>
-        <p:nvSpPr>
-          <p:cNvPr id="16" name="TextBox 15"/>
-          <p:cNvSpPr txBox="1"/>
-          <p:nvPr/>
-        </p:nvSpPr>
-        <p:spPr>
-          <a:xfrm>
-            <a:off x="658368" y="6419088"/>
-            <a:ext cx="8686800" cy="228600"/>
-          </a:xfrm>
-          <a:prstGeom prst="rect">
-            <a:avLst/>
-          </a:prstGeom>
-          <a:noFill/>
-        </p:spPr>
-        <p:txBody>
-          <a:bodyPr wrap="square" anchor="t">
-            <a:spAutoFit/>
-          </a:bodyPr>
-          <a:lstStyle/>
-          <a:p>
-            <a:pPr algn="l"/>
-            <a:r>
-              <a:rPr sz="1000" b="0">
-                <a:solidFill>
-                  <a:srgbClr val="5A7184"/>
-                </a:solidFill>
-                <a:latin typeface="Aptos"/>
-              </a:rPr>
-              <a:t>Message for judges: the product is not only about generating rows; it is about making synthetic planning data usable and governed.</a:t>
-            </a:r>
-          </a:p>
-        </p:txBody>
-      </p:sp>
     </p:spTree>
   </p:cSld>
   <p:clrMapOvr>
@@ -3869,14 +3125,6 @@
 <file path=ppt/slides/slide2.xml><?xml version="1.0" encoding="utf-8"?>
 <p:sld xmlns:a="http://schemas.openxmlformats.org/drawingml/2006/main" xmlns:p="http://schemas.openxmlformats.org/presentationml/2006/main" xmlns:r="http://schemas.openxmlformats.org/officeDocument/2006/relationships">
   <p:cSld>
-    <p:bg>
-      <p:bgPr>
-        <a:solidFill>
-          <a:srgbClr val="F4F7F4"/>
-        </a:solidFill>
-        <a:effectLst/>
-      </p:bgPr>
-    </p:bg>
     <p:spTree>
       <p:nvGrpSpPr>
         <p:cNvPr id="1" name=""/>
@@ -3884,299 +3132,9 @@
         <p:nvPr/>
       </p:nvGrpSpPr>
       <p:grpSpPr/>
-      <p:sp>
-        <p:nvSpPr>
-          <p:cNvPr id="2" name="Oval 1"/>
-          <p:cNvSpPr/>
-          <p:nvPr/>
-        </p:nvSpPr>
-        <p:spPr>
-          <a:xfrm>
-            <a:off x="-411480" y="-502920"/>
-            <a:ext cx="2651760" cy="2651760"/>
-          </a:xfrm>
-          <a:prstGeom prst="ellipse">
-            <a:avLst/>
-          </a:prstGeom>
-          <a:solidFill>
-            <a:srgbClr val="DFF8EC"/>
-          </a:solidFill>
-          <a:ln>
-            <a:noFill/>
-          </a:ln>
-        </p:spPr>
-        <p:style>
-          <a:lnRef idx="1">
-            <a:schemeClr val="accent1"/>
-          </a:lnRef>
-          <a:fillRef idx="3">
-            <a:schemeClr val="accent1"/>
-          </a:fillRef>
-          <a:effectRef idx="2">
-            <a:schemeClr val="accent1"/>
-          </a:effectRef>
-          <a:fontRef idx="minor">
-            <a:schemeClr val="lt1"/>
-          </a:fontRef>
-        </p:style>
-        <p:txBody>
-          <a:bodyPr rtlCol="0" anchor="ctr"/>
-          <a:lstStyle/>
-          <a:p>
-            <a:pPr algn="ctr"/>
-          </a:p>
-        </p:txBody>
-      </p:sp>
-      <p:sp>
-        <p:nvSpPr>
-          <p:cNvPr id="3" name="Oval 2"/>
-          <p:cNvSpPr/>
-          <p:nvPr/>
-        </p:nvSpPr>
-        <p:spPr>
-          <a:xfrm>
-            <a:off x="10241280" y="-365760"/>
-            <a:ext cx="1920240" cy="1920240"/>
-          </a:xfrm>
-          <a:prstGeom prst="ellipse">
-            <a:avLst/>
-          </a:prstGeom>
-          <a:solidFill>
-            <a:srgbClr val="F2E7CF"/>
-          </a:solidFill>
-          <a:ln>
-            <a:noFill/>
-          </a:ln>
-        </p:spPr>
-        <p:style>
-          <a:lnRef idx="1">
-            <a:schemeClr val="accent1"/>
-          </a:lnRef>
-          <a:fillRef idx="3">
-            <a:schemeClr val="accent1"/>
-          </a:fillRef>
-          <a:effectRef idx="2">
-            <a:schemeClr val="accent1"/>
-          </a:effectRef>
-          <a:fontRef idx="minor">
-            <a:schemeClr val="lt1"/>
-          </a:fontRef>
-        </p:style>
-        <p:txBody>
-          <a:bodyPr rtlCol="0" anchor="ctr"/>
-          <a:lstStyle/>
-          <a:p>
-            <a:pPr algn="ctr"/>
-          </a:p>
-        </p:txBody>
-      </p:sp>
-      <p:sp>
-        <p:nvSpPr>
-          <p:cNvPr id="4" name="TextBox 3"/>
-          <p:cNvSpPr txBox="1"/>
-          <p:nvPr/>
-        </p:nvSpPr>
-        <p:spPr>
-          <a:xfrm>
-            <a:off x="658368" y="384048"/>
-            <a:ext cx="4572000" cy="320040"/>
-          </a:xfrm>
-          <a:prstGeom prst="rect">
-            <a:avLst/>
-          </a:prstGeom>
-          <a:noFill/>
-        </p:spPr>
-        <p:txBody>
-          <a:bodyPr wrap="square" anchor="t">
-            <a:spAutoFit/>
-          </a:bodyPr>
-          <a:lstStyle/>
-          <a:p>
-            <a:pPr algn="l"/>
-            <a:r>
-              <a:rPr sz="1100" b="1">
-                <a:solidFill>
-                  <a:srgbClr val="0F7C82"/>
-                </a:solidFill>
-                <a:latin typeface="Aptos"/>
-              </a:rPr>
-              <a:t>FEATURES</a:t>
-            </a:r>
-          </a:p>
-        </p:txBody>
-      </p:sp>
-      <p:sp>
-        <p:nvSpPr>
-          <p:cNvPr id="5" name="TextBox 4"/>
-          <p:cNvSpPr txBox="1"/>
-          <p:nvPr/>
-        </p:nvSpPr>
-        <p:spPr>
-          <a:xfrm>
-            <a:off x="658368" y="658368"/>
-            <a:ext cx="8046720" cy="749808"/>
-          </a:xfrm>
-          <a:prstGeom prst="rect">
-            <a:avLst/>
-          </a:prstGeom>
-          <a:noFill/>
-        </p:spPr>
-        <p:txBody>
-          <a:bodyPr wrap="square" anchor="t">
-            <a:spAutoFit/>
-          </a:bodyPr>
-          <a:lstStyle/>
-          <a:p>
-            <a:pPr algn="l"/>
-            <a:r>
-              <a:rPr sz="2500" b="1">
-                <a:solidFill>
-                  <a:srgbClr val="102A43"/>
-                </a:solidFill>
-                <a:latin typeface="Aptos Display"/>
-              </a:rPr>
-              <a:t>What The Studio Actually Does</a:t>
-            </a:r>
-          </a:p>
-        </p:txBody>
-      </p:sp>
-      <p:sp>
-        <p:nvSpPr>
-          <p:cNvPr id="6" name="TextBox 5"/>
-          <p:cNvSpPr txBox="1"/>
-          <p:nvPr/>
-        </p:nvSpPr>
-        <p:spPr>
-          <a:xfrm>
-            <a:off x="658368" y="1417320"/>
-            <a:ext cx="8138160" cy="237744"/>
-          </a:xfrm>
-          <a:prstGeom prst="rect">
-            <a:avLst/>
-          </a:prstGeom>
-          <a:noFill/>
-        </p:spPr>
-        <p:txBody>
-          <a:bodyPr wrap="square" anchor="t">
-            <a:spAutoFit/>
-          </a:bodyPr>
-          <a:lstStyle/>
-          <a:p>
-            <a:pPr algn="l"/>
-            <a:r>
-              <a:rPr sz="1300" b="0">
-                <a:solidFill>
-                  <a:srgbClr val="5A7184"/>
-                </a:solidFill>
-                <a:latin typeface="Aptos"/>
-              </a:rPr>
-              <a:t>Saved demo reliability, visible evaluation, and exportable artifacts for innovation teams.</a:t>
-            </a:r>
-          </a:p>
-        </p:txBody>
-      </p:sp>
-      <p:sp>
-        <p:nvSpPr>
-          <p:cNvPr id="7" name="Rounded Rectangle 6"/>
-          <p:cNvSpPr/>
-          <p:nvPr/>
-        </p:nvSpPr>
-        <p:spPr>
-          <a:xfrm>
-            <a:off x="10789920" y="384048"/>
-            <a:ext cx="731520" cy="347472"/>
-          </a:xfrm>
-          <a:prstGeom prst="roundRect">
-            <a:avLst/>
-          </a:prstGeom>
-          <a:solidFill>
-            <a:srgbClr val="FFFFFF"/>
-          </a:solidFill>
-          <a:ln w="12700">
-            <a:solidFill>
-              <a:srgbClr val="DCE3EA"/>
-            </a:solidFill>
-          </a:ln>
-        </p:spPr>
-        <p:style>
-          <a:lnRef idx="1">
-            <a:schemeClr val="accent1"/>
-          </a:lnRef>
-          <a:fillRef idx="3">
-            <a:schemeClr val="accent1"/>
-          </a:fillRef>
-          <a:effectRef idx="2">
-            <a:schemeClr val="accent1"/>
-          </a:effectRef>
-          <a:fontRef idx="minor">
-            <a:schemeClr val="lt1"/>
-          </a:fontRef>
-        </p:style>
-        <p:txBody>
-          <a:bodyPr rtlCol="0" anchor="ctr"/>
-          <a:lstStyle/>
-          <a:p>
-            <a:pPr algn="ctr"/>
-            <a:r>
-              <a:rPr sz="1100" b="1">
-                <a:solidFill>
-                  <a:srgbClr val="5A7184"/>
-                </a:solidFill>
-                <a:latin typeface="Aptos"/>
-              </a:rPr>
-              <a:t>2/3</a:t>
-            </a:r>
-          </a:p>
-        </p:txBody>
-      </p:sp>
-      <p:sp>
-        <p:nvSpPr>
-          <p:cNvPr id="8" name="Rounded Rectangle 7"/>
-          <p:cNvSpPr/>
-          <p:nvPr/>
-        </p:nvSpPr>
-        <p:spPr>
-          <a:xfrm>
-            <a:off x="566928" y="1664208"/>
-            <a:ext cx="6583680" cy="4846320"/>
-          </a:xfrm>
-          <a:prstGeom prst="roundRect">
-            <a:avLst/>
-          </a:prstGeom>
-          <a:solidFill>
-            <a:srgbClr val="FFFFFF"/>
-          </a:solidFill>
-          <a:ln w="12700">
-            <a:solidFill>
-              <a:srgbClr val="E4E9ED"/>
-            </a:solidFill>
-          </a:ln>
-        </p:spPr>
-        <p:style>
-          <a:lnRef idx="1">
-            <a:schemeClr val="accent1"/>
-          </a:lnRef>
-          <a:fillRef idx="3">
-            <a:schemeClr val="accent1"/>
-          </a:fillRef>
-          <a:effectRef idx="2">
-            <a:schemeClr val="accent1"/>
-          </a:effectRef>
-          <a:fontRef idx="minor">
-            <a:schemeClr val="lt1"/>
-          </a:fontRef>
-        </p:style>
-        <p:txBody>
-          <a:bodyPr rtlCol="0" anchor="ctr"/>
-          <a:lstStyle/>
-          <a:p>
-            <a:pPr algn="ctr"/>
-          </a:p>
-        </p:txBody>
-      </p:sp>
       <p:pic>
         <p:nvPicPr>
-          <p:cNvPr id="9" name="Picture 8" descr="run-focus.png"/>
+          <p:cNvPr id="2" name="Picture 1" descr="slide-2.png"/>
           <p:cNvPicPr>
             <a:picLocks noChangeAspect="1"/>
           </p:cNvPicPr>
@@ -4190,460 +3148,14 @@
         </p:blipFill>
         <p:spPr>
           <a:xfrm>
-            <a:off x="768096" y="1865376"/>
-            <a:ext cx="6181344" cy="4123944"/>
+            <a:off x="0" y="0"/>
+            <a:ext cx="12192000" cy="6858000"/>
           </a:xfrm>
           <a:prstGeom prst="rect">
             <a:avLst/>
           </a:prstGeom>
         </p:spPr>
       </p:pic>
-      <p:sp>
-        <p:nvSpPr>
-          <p:cNvPr id="10" name="Rounded Rectangle 9"/>
-          <p:cNvSpPr/>
-          <p:nvPr/>
-        </p:nvSpPr>
-        <p:spPr>
-          <a:xfrm>
-            <a:off x="896112" y="1755648"/>
-            <a:ext cx="1316736" cy="310896"/>
-          </a:xfrm>
-          <a:prstGeom prst="roundRect">
-            <a:avLst/>
-          </a:prstGeom>
-          <a:solidFill>
-            <a:srgbClr val="DFF8EC"/>
-          </a:solidFill>
-          <a:ln>
-            <a:noFill/>
-          </a:ln>
-        </p:spPr>
-        <p:style>
-          <a:lnRef idx="1">
-            <a:schemeClr val="accent1"/>
-          </a:lnRef>
-          <a:fillRef idx="3">
-            <a:schemeClr val="accent1"/>
-          </a:fillRef>
-          <a:effectRef idx="2">
-            <a:schemeClr val="accent1"/>
-          </a:effectRef>
-          <a:fontRef idx="minor">
-            <a:schemeClr val="lt1"/>
-          </a:fontRef>
-        </p:style>
-        <p:txBody>
-          <a:bodyPr rtlCol="0" anchor="ctr"/>
-          <a:lstStyle/>
-          <a:p>
-            <a:pPr algn="ctr"/>
-            <a:r>
-              <a:rPr sz="1000" b="1">
-                <a:solidFill>
-                  <a:srgbClr val="096149"/>
-                </a:solidFill>
-                <a:latin typeface="Aptos"/>
-              </a:rPr>
-              <a:t>Saved demo run</a:t>
-            </a:r>
-          </a:p>
-        </p:txBody>
-      </p:sp>
-      <p:sp>
-        <p:nvSpPr>
-          <p:cNvPr id="11" name="Rounded Rectangle 10"/>
-          <p:cNvSpPr/>
-          <p:nvPr/>
-        </p:nvSpPr>
-        <p:spPr>
-          <a:xfrm>
-            <a:off x="2450592" y="1755648"/>
-            <a:ext cx="1316736" cy="310896"/>
-          </a:xfrm>
-          <a:prstGeom prst="roundRect">
-            <a:avLst/>
-          </a:prstGeom>
-          <a:solidFill>
-            <a:srgbClr val="F2E7CF"/>
-          </a:solidFill>
-          <a:ln>
-            <a:noFill/>
-          </a:ln>
-        </p:spPr>
-        <p:style>
-          <a:lnRef idx="1">
-            <a:schemeClr val="accent1"/>
-          </a:lnRef>
-          <a:fillRef idx="3">
-            <a:schemeClr val="accent1"/>
-          </a:fillRef>
-          <a:effectRef idx="2">
-            <a:schemeClr val="accent1"/>
-          </a:effectRef>
-          <a:fontRef idx="minor">
-            <a:schemeClr val="lt1"/>
-          </a:fontRef>
-        </p:style>
-        <p:txBody>
-          <a:bodyPr rtlCol="0" anchor="ctr"/>
-          <a:lstStyle/>
-          <a:p>
-            <a:pPr algn="ctr"/>
-            <a:r>
-              <a:rPr sz="1000" b="1">
-                <a:solidFill>
-                  <a:srgbClr val="7A5200"/>
-                </a:solidFill>
-                <a:latin typeface="Aptos"/>
-              </a:rPr>
-              <a:t>Scenario controls</a:t>
-            </a:r>
-          </a:p>
-        </p:txBody>
-      </p:sp>
-      <p:sp>
-        <p:nvSpPr>
-          <p:cNvPr id="12" name="Rounded Rectangle 11"/>
-          <p:cNvSpPr/>
-          <p:nvPr/>
-        </p:nvSpPr>
-        <p:spPr>
-          <a:xfrm>
-            <a:off x="3986784" y="1755648"/>
-            <a:ext cx="1316736" cy="310896"/>
-          </a:xfrm>
-          <a:prstGeom prst="roundRect">
-            <a:avLst/>
-          </a:prstGeom>
-          <a:solidFill>
-            <a:srgbClr val="E7F2FF"/>
-          </a:solidFill>
-          <a:ln>
-            <a:noFill/>
-          </a:ln>
-        </p:spPr>
-        <p:style>
-          <a:lnRef idx="1">
-            <a:schemeClr val="accent1"/>
-          </a:lnRef>
-          <a:fillRef idx="3">
-            <a:schemeClr val="accent1"/>
-          </a:fillRef>
-          <a:effectRef idx="2">
-            <a:schemeClr val="accent1"/>
-          </a:effectRef>
-          <a:fontRef idx="minor">
-            <a:schemeClr val="lt1"/>
-          </a:fontRef>
-        </p:style>
-        <p:txBody>
-          <a:bodyPr rtlCol="0" anchor="ctr"/>
-          <a:lstStyle/>
-          <a:p>
-            <a:pPr algn="ctr"/>
-            <a:r>
-              <a:rPr sz="1000" b="1">
-                <a:solidFill>
-                  <a:srgbClr val="0F7C82"/>
-                </a:solidFill>
-                <a:latin typeface="Aptos"/>
-              </a:rPr>
-              <a:t>Metrics</a:t>
-            </a:r>
-          </a:p>
-        </p:txBody>
-      </p:sp>
-      <p:sp>
-        <p:nvSpPr>
-          <p:cNvPr id="13" name="Rounded Rectangle 12"/>
-          <p:cNvSpPr/>
-          <p:nvPr/>
-        </p:nvSpPr>
-        <p:spPr>
-          <a:xfrm>
-            <a:off x="5056632" y="5687568"/>
-            <a:ext cx="1316736" cy="310896"/>
-          </a:xfrm>
-          <a:prstGeom prst="roundRect">
-            <a:avLst/>
-          </a:prstGeom>
-          <a:solidFill>
-            <a:srgbClr val="FFEFEA"/>
-          </a:solidFill>
-          <a:ln>
-            <a:noFill/>
-          </a:ln>
-        </p:spPr>
-        <p:style>
-          <a:lnRef idx="1">
-            <a:schemeClr val="accent1"/>
-          </a:lnRef>
-          <a:fillRef idx="3">
-            <a:schemeClr val="accent1"/>
-          </a:fillRef>
-          <a:effectRef idx="2">
-            <a:schemeClr val="accent1"/>
-          </a:effectRef>
-          <a:fontRef idx="minor">
-            <a:schemeClr val="lt1"/>
-          </a:fontRef>
-        </p:style>
-        <p:txBody>
-          <a:bodyPr rtlCol="0" anchor="ctr"/>
-          <a:lstStyle/>
-          <a:p>
-            <a:pPr algn="ctr"/>
-            <a:r>
-              <a:rPr sz="1000" b="1">
-                <a:solidFill>
-                  <a:srgbClr val="9A3412"/>
-                </a:solidFill>
-                <a:latin typeface="Aptos"/>
-              </a:rPr>
-              <a:t>Pitch + cautions</a:t>
-            </a:r>
-          </a:p>
-        </p:txBody>
-      </p:sp>
-      <p:sp>
-        <p:nvSpPr>
-          <p:cNvPr id="14" name="TextBox 13"/>
-          <p:cNvSpPr txBox="1"/>
-          <p:nvPr/>
-        </p:nvSpPr>
-        <p:spPr>
-          <a:xfrm>
-            <a:off x="7406640" y="1755648"/>
-            <a:ext cx="3566160" cy="320040"/>
-          </a:xfrm>
-          <a:prstGeom prst="rect">
-            <a:avLst/>
-          </a:prstGeom>
-          <a:noFill/>
-        </p:spPr>
-        <p:txBody>
-          <a:bodyPr wrap="square" anchor="t">
-            <a:spAutoFit/>
-          </a:bodyPr>
-          <a:lstStyle/>
-          <a:p>
-            <a:pPr algn="l"/>
-            <a:r>
-              <a:rPr sz="1200" b="1">
-                <a:solidFill>
-                  <a:srgbClr val="0F7C82"/>
-                </a:solidFill>
-                <a:latin typeface="Aptos"/>
-              </a:rPr>
-              <a:t>Feature Highlights</a:t>
-            </a:r>
-          </a:p>
-        </p:txBody>
-      </p:sp>
-      <p:sp>
-        <p:nvSpPr>
-          <p:cNvPr id="15" name="TextBox 14"/>
-          <p:cNvSpPr txBox="1"/>
-          <p:nvPr/>
-        </p:nvSpPr>
-        <p:spPr>
-          <a:xfrm>
-            <a:off x="7406640" y="2011680"/>
-            <a:ext cx="3657600" cy="2240280"/>
-          </a:xfrm>
-          <a:prstGeom prst="rect">
-            <a:avLst/>
-          </a:prstGeom>
-          <a:noFill/>
-        </p:spPr>
-        <p:txBody>
-          <a:bodyPr wrap="square" anchor="t" lIns="0" rIns="0">
-            <a:spAutoFit/>
-          </a:bodyPr>
-          <a:lstStyle/>
-          <a:p>
-            <a:pPr>
-              <a:spcAft>
-                <a:spcPts val="1000"/>
-              </a:spcAft>
-              <a:defRPr sz="1400">
-                <a:solidFill>
-                  <a:srgbClr val="102A43"/>
-                </a:solidFill>
-                <a:latin typeface="Aptos"/>
-              </a:defRPr>
-            </a:pPr>
-            <a:r>
-              <a:t>Southlake-specific scenarios aligned to distributed-network planning needs</a:t>
-            </a:r>
-          </a:p>
-          <a:p>
-            <a:pPr>
-              <a:spcAft>
-                <a:spcPts val="1000"/>
-              </a:spcAft>
-              <a:defRPr sz="1400">
-                <a:solidFill>
-                  <a:srgbClr val="102A43"/>
-                </a:solidFill>
-                <a:latin typeface="Aptos"/>
-              </a:defRPr>
-            </a:pPr>
-            <a:r>
-              <a:t>One-click saved demo runs plus optional fresh synthesis or CSV upload</a:t>
-            </a:r>
-          </a:p>
-          <a:p>
-            <a:pPr>
-              <a:spcAft>
-                <a:spcPts val="1000"/>
-              </a:spcAft>
-              <a:defRPr sz="1400">
-                <a:solidFill>
-                  <a:srgbClr val="102A43"/>
-                </a:solidFill>
-                <a:latin typeface="Aptos"/>
-              </a:defRPr>
-            </a:pPr>
-            <a:r>
-              <a:t>Visible fidelity, privacy, and utility metrics in one screen</a:t>
-            </a:r>
-          </a:p>
-          <a:p>
-            <a:pPr>
-              <a:spcAft>
-                <a:spcPts val="1000"/>
-              </a:spcAft>
-              <a:defRPr sz="1400">
-                <a:solidFill>
-                  <a:srgbClr val="102A43"/>
-                </a:solidFill>
-                <a:latin typeface="Aptos"/>
-              </a:defRPr>
-            </a:pPr>
-            <a:r>
-              <a:t>Auto-generated methodology, features, and cautions for pitch preparation</a:t>
-            </a:r>
-          </a:p>
-        </p:txBody>
-      </p:sp>
-      <p:sp>
-        <p:nvSpPr>
-          <p:cNvPr id="16" name="Rounded Rectangle 15"/>
-          <p:cNvSpPr/>
-          <p:nvPr/>
-        </p:nvSpPr>
-        <p:spPr>
-          <a:xfrm>
-            <a:off x="7406640" y="4498848"/>
-            <a:ext cx="3657600" cy="1389888"/>
-          </a:xfrm>
-          <a:prstGeom prst="roundRect">
-            <a:avLst/>
-          </a:prstGeom>
-          <a:solidFill>
-            <a:srgbClr val="1E293B"/>
-          </a:solidFill>
-          <a:ln>
-            <a:noFill/>
-          </a:ln>
-        </p:spPr>
-        <p:style>
-          <a:lnRef idx="1">
-            <a:schemeClr val="accent1"/>
-          </a:lnRef>
-          <a:fillRef idx="3">
-            <a:schemeClr val="accent1"/>
-          </a:fillRef>
-          <a:effectRef idx="2">
-            <a:schemeClr val="accent1"/>
-          </a:effectRef>
-          <a:fontRef idx="minor">
-            <a:schemeClr val="lt1"/>
-          </a:fontRef>
-        </p:style>
-        <p:txBody>
-          <a:bodyPr rtlCol="0" anchor="t" wrap="square"/>
-          <a:lstStyle/>
-          <a:p>
-            <a:pPr algn="ctr"/>
-            <a:r>
-              <a:rPr sz="1100" b="1">
-                <a:solidFill>
-                  <a:srgbClr val="AEEFD7"/>
-                </a:solidFill>
-                <a:latin typeface="Aptos"/>
-              </a:rPr>
-              <a:t>Primary saved run</a:t>
-            </a:r>
-          </a:p>
-          <a:p>
-            <a:pPr>
-              <a:spcAft>
-                <a:spcPts val="600"/>
-              </a:spcAft>
-              <a:defRPr sz="1600" b="1">
-                <a:solidFill>
-                  <a:srgbClr val="FFFFFF"/>
-                </a:solidFill>
-                <a:latin typeface="Aptos"/>
-              </a:defRPr>
-            </a:pPr>
-            <a:r>
-              <a:t>Distributed Campus Routing | run 72c9c81912</a:t>
-            </a:r>
-          </a:p>
-          <a:p>
-            <a:pPr>
-              <a:defRPr sz="1300">
-                <a:solidFill>
-                  <a:srgbClr val="FFFFFF"/>
-                </a:solidFill>
-                <a:latin typeface="Aptos"/>
-              </a:defRPr>
-            </a:pPr>
-            <a:r>
-              <a:t>Fidelity 81.54   Privacy 100.0   Utility 88.92</a:t>
-            </a:r>
-          </a:p>
-        </p:txBody>
-      </p:sp>
-      <p:sp>
-        <p:nvSpPr>
-          <p:cNvPr id="17" name="TextBox 16"/>
-          <p:cNvSpPr txBox="1"/>
-          <p:nvPr/>
-        </p:nvSpPr>
-        <p:spPr>
-          <a:xfrm>
-            <a:off x="658368" y="6419088"/>
-            <a:ext cx="8686800" cy="228600"/>
-          </a:xfrm>
-          <a:prstGeom prst="rect">
-            <a:avLst/>
-          </a:prstGeom>
-          <a:noFill/>
-        </p:spPr>
-        <p:txBody>
-          <a:bodyPr wrap="square" anchor="t">
-            <a:spAutoFit/>
-          </a:bodyPr>
-          <a:lstStyle/>
-          <a:p>
-            <a:pPr algn="l"/>
-            <a:r>
-              <a:rPr sz="1000" b="0">
-                <a:solidFill>
-                  <a:srgbClr val="5A7184"/>
-                </a:solidFill>
-                <a:latin typeface="Aptos"/>
-              </a:rPr>
-              <a:t>Pitch note: judges can see both the data product and the explanation product, with a reliable saved-run path if live generation is slow.</a:t>
-            </a:r>
-          </a:p>
-        </p:txBody>
-      </p:sp>
     </p:spTree>
   </p:cSld>
   <p:clrMapOvr>
@@ -4655,14 +3167,6 @@
 <file path=ppt/slides/slide3.xml><?xml version="1.0" encoding="utf-8"?>
 <p:sld xmlns:a="http://schemas.openxmlformats.org/drawingml/2006/main" xmlns:p="http://schemas.openxmlformats.org/presentationml/2006/main" xmlns:r="http://schemas.openxmlformats.org/officeDocument/2006/relationships">
   <p:cSld>
-    <p:bg>
-      <p:bgPr>
-        <a:solidFill>
-          <a:srgbClr val="F4F7F4"/>
-        </a:solidFill>
-        <a:effectLst/>
-      </p:bgPr>
-    </p:bg>
     <p:spTree>
       <p:nvGrpSpPr>
         <p:cNvPr id="1" name=""/>
@@ -4670,570 +3174,30 @@
         <p:nvPr/>
       </p:nvGrpSpPr>
       <p:grpSpPr/>
-      <p:sp>
-        <p:nvSpPr>
-          <p:cNvPr id="2" name="Oval 1"/>
-          <p:cNvSpPr/>
+      <p:pic>
+        <p:nvPicPr>
+          <p:cNvPr id="2" name="Picture 1" descr="slide-3.png"/>
+          <p:cNvPicPr>
+            <a:picLocks noChangeAspect="1"/>
+          </p:cNvPicPr>
           <p:nvPr/>
-        </p:nvSpPr>
+        </p:nvPicPr>
+        <p:blipFill>
+          <a:blip r:embed="rId2"/>
+          <a:stretch>
+            <a:fillRect/>
+          </a:stretch>
+        </p:blipFill>
         <p:spPr>
           <a:xfrm>
-            <a:off x="-411480" y="-502920"/>
-            <a:ext cx="2651760" cy="2651760"/>
-          </a:xfrm>
-          <a:prstGeom prst="ellipse">
-            <a:avLst/>
-          </a:prstGeom>
-          <a:solidFill>
-            <a:srgbClr val="DFF8EC"/>
-          </a:solidFill>
-          <a:ln>
-            <a:noFill/>
-          </a:ln>
-        </p:spPr>
-        <p:style>
-          <a:lnRef idx="1">
-            <a:schemeClr val="accent1"/>
-          </a:lnRef>
-          <a:fillRef idx="3">
-            <a:schemeClr val="accent1"/>
-          </a:fillRef>
-          <a:effectRef idx="2">
-            <a:schemeClr val="accent1"/>
-          </a:effectRef>
-          <a:fontRef idx="minor">
-            <a:schemeClr val="lt1"/>
-          </a:fontRef>
-        </p:style>
-        <p:txBody>
-          <a:bodyPr rtlCol="0" anchor="ctr"/>
-          <a:lstStyle/>
-          <a:p>
-            <a:pPr algn="ctr"/>
-          </a:p>
-        </p:txBody>
-      </p:sp>
-      <p:sp>
-        <p:nvSpPr>
-          <p:cNvPr id="3" name="Oval 2"/>
-          <p:cNvSpPr/>
-          <p:nvPr/>
-        </p:nvSpPr>
-        <p:spPr>
-          <a:xfrm>
-            <a:off x="10241280" y="-365760"/>
-            <a:ext cx="1920240" cy="1920240"/>
-          </a:xfrm>
-          <a:prstGeom prst="ellipse">
-            <a:avLst/>
-          </a:prstGeom>
-          <a:solidFill>
-            <a:srgbClr val="F2E7CF"/>
-          </a:solidFill>
-          <a:ln>
-            <a:noFill/>
-          </a:ln>
-        </p:spPr>
-        <p:style>
-          <a:lnRef idx="1">
-            <a:schemeClr val="accent1"/>
-          </a:lnRef>
-          <a:fillRef idx="3">
-            <a:schemeClr val="accent1"/>
-          </a:fillRef>
-          <a:effectRef idx="2">
-            <a:schemeClr val="accent1"/>
-          </a:effectRef>
-          <a:fontRef idx="minor">
-            <a:schemeClr val="lt1"/>
-          </a:fontRef>
-        </p:style>
-        <p:txBody>
-          <a:bodyPr rtlCol="0" anchor="ctr"/>
-          <a:lstStyle/>
-          <a:p>
-            <a:pPr algn="ctr"/>
-          </a:p>
-        </p:txBody>
-      </p:sp>
-      <p:sp>
-        <p:nvSpPr>
-          <p:cNvPr id="4" name="TextBox 3"/>
-          <p:cNvSpPr txBox="1"/>
-          <p:nvPr/>
-        </p:nvSpPr>
-        <p:spPr>
-          <a:xfrm>
-            <a:off x="658368" y="384048"/>
-            <a:ext cx="4572000" cy="320040"/>
+            <a:off x="0" y="0"/>
+            <a:ext cx="12192000" cy="6858000"/>
           </a:xfrm>
           <a:prstGeom prst="rect">
             <a:avLst/>
           </a:prstGeom>
-          <a:noFill/>
         </p:spPr>
-        <p:txBody>
-          <a:bodyPr wrap="square" anchor="t">
-            <a:spAutoFit/>
-          </a:bodyPr>
-          <a:lstStyle/>
-          <a:p>
-            <a:pPr algn="l"/>
-            <a:r>
-              <a:rPr sz="1100" b="1">
-                <a:solidFill>
-                  <a:srgbClr val="0F7C82"/>
-                </a:solidFill>
-                <a:latin typeface="Aptos"/>
-              </a:rPr>
-              <a:t>CAUTIONS</a:t>
-            </a:r>
-          </a:p>
-        </p:txBody>
-      </p:sp>
-      <p:sp>
-        <p:nvSpPr>
-          <p:cNvPr id="5" name="TextBox 4"/>
-          <p:cNvSpPr txBox="1"/>
-          <p:nvPr/>
-        </p:nvSpPr>
-        <p:spPr>
-          <a:xfrm>
-            <a:off x="658368" y="658368"/>
-            <a:ext cx="8046720" cy="960120"/>
-          </a:xfrm>
-          <a:prstGeom prst="rect">
-            <a:avLst/>
-          </a:prstGeom>
-          <a:noFill/>
-        </p:spPr>
-        <p:txBody>
-          <a:bodyPr wrap="square" anchor="t">
-            <a:spAutoFit/>
-          </a:bodyPr>
-          <a:lstStyle/>
-          <a:p>
-            <a:pPr algn="l"/>
-            <a:r>
-              <a:rPr sz="2200" b="1">
-                <a:solidFill>
-                  <a:srgbClr val="102A43"/>
-                </a:solidFill>
-                <a:latin typeface="Aptos Display"/>
-              </a:rPr>
-              <a:t>What The Studio Is Safe For, And What It Is Not</a:t>
-            </a:r>
-          </a:p>
-        </p:txBody>
-      </p:sp>
-      <p:sp>
-        <p:nvSpPr>
-          <p:cNvPr id="6" name="TextBox 5"/>
-          <p:cNvSpPr txBox="1"/>
-          <p:nvPr/>
-        </p:nvSpPr>
-        <p:spPr>
-          <a:xfrm>
-            <a:off x="658368" y="1609344"/>
-            <a:ext cx="8138160" cy="237744"/>
-          </a:xfrm>
-          <a:prstGeom prst="rect">
-            <a:avLst/>
-          </a:prstGeom>
-          <a:noFill/>
-        </p:spPr>
-        <p:txBody>
-          <a:bodyPr wrap="square" anchor="t">
-            <a:spAutoFit/>
-          </a:bodyPr>
-          <a:lstStyle/>
-          <a:p>
-            <a:pPr algn="l"/>
-            <a:r>
-              <a:rPr sz="1300" b="0">
-                <a:solidFill>
-                  <a:srgbClr val="5A7184"/>
-                </a:solidFill>
-                <a:latin typeface="Aptos"/>
-              </a:rPr>
-              <a:t>Synthetic data is useful for planning and experimentation, but it is not local operational truth.</a:t>
-            </a:r>
-          </a:p>
-        </p:txBody>
-      </p:sp>
-      <p:sp>
-        <p:nvSpPr>
-          <p:cNvPr id="7" name="Rounded Rectangle 6"/>
-          <p:cNvSpPr/>
-          <p:nvPr/>
-        </p:nvSpPr>
-        <p:spPr>
-          <a:xfrm>
-            <a:off x="10789920" y="384048"/>
-            <a:ext cx="731520" cy="347472"/>
-          </a:xfrm>
-          <a:prstGeom prst="roundRect">
-            <a:avLst/>
-          </a:prstGeom>
-          <a:solidFill>
-            <a:srgbClr val="FFFFFF"/>
-          </a:solidFill>
-          <a:ln w="12700">
-            <a:solidFill>
-              <a:srgbClr val="DCE3EA"/>
-            </a:solidFill>
-          </a:ln>
-        </p:spPr>
-        <p:style>
-          <a:lnRef idx="1">
-            <a:schemeClr val="accent1"/>
-          </a:lnRef>
-          <a:fillRef idx="3">
-            <a:schemeClr val="accent1"/>
-          </a:fillRef>
-          <a:effectRef idx="2">
-            <a:schemeClr val="accent1"/>
-          </a:effectRef>
-          <a:fontRef idx="minor">
-            <a:schemeClr val="lt1"/>
-          </a:fontRef>
-        </p:style>
-        <p:txBody>
-          <a:bodyPr rtlCol="0" anchor="ctr"/>
-          <a:lstStyle/>
-          <a:p>
-            <a:pPr algn="ctr"/>
-            <a:r>
-              <a:rPr sz="1100" b="1">
-                <a:solidFill>
-                  <a:srgbClr val="5A7184"/>
-                </a:solidFill>
-                <a:latin typeface="Aptos"/>
-              </a:rPr>
-              <a:t>3/3</a:t>
-            </a:r>
-          </a:p>
-        </p:txBody>
-      </p:sp>
-      <p:sp>
-        <p:nvSpPr>
-          <p:cNvPr id="8" name="Rounded Rectangle 7"/>
-          <p:cNvSpPr/>
-          <p:nvPr/>
-        </p:nvSpPr>
-        <p:spPr>
-          <a:xfrm>
-            <a:off x="566928" y="1993392"/>
-            <a:ext cx="5358384" cy="4151376"/>
-          </a:xfrm>
-          <a:prstGeom prst="roundRect">
-            <a:avLst/>
-          </a:prstGeom>
-          <a:solidFill>
-            <a:srgbClr val="DFF8EC"/>
-          </a:solidFill>
-          <a:ln>
-            <a:noFill/>
-          </a:ln>
-        </p:spPr>
-        <p:style>
-          <a:lnRef idx="1">
-            <a:schemeClr val="accent1"/>
-          </a:lnRef>
-          <a:fillRef idx="3">
-            <a:schemeClr val="accent1"/>
-          </a:fillRef>
-          <a:effectRef idx="2">
-            <a:schemeClr val="accent1"/>
-          </a:effectRef>
-          <a:fontRef idx="minor">
-            <a:schemeClr val="lt1"/>
-          </a:fontRef>
-        </p:style>
-        <p:txBody>
-          <a:bodyPr rtlCol="0" anchor="ctr" wrap="square"/>
-          <a:lstStyle/>
-          <a:p>
-            <a:pPr algn="ctr"/>
-            <a:r>
-              <a:rPr sz="2400" b="1">
-                <a:solidFill>
-                  <a:srgbClr val="096149"/>
-                </a:solidFill>
-                <a:latin typeface="Aptos Display"/>
-              </a:rPr>
-              <a:t>Good For</a:t>
-            </a:r>
-          </a:p>
-          <a:p>
-            <a:pPr>
-              <a:spcAft>
-                <a:spcPts val="1000"/>
-              </a:spcAft>
-              <a:defRPr sz="1600">
-                <a:solidFill>
-                  <a:srgbClr val="102A43"/>
-                </a:solidFill>
-                <a:latin typeface="Aptos"/>
-              </a:defRPr>
-            </a:pPr>
-            <a:r>
-              <a:t>Planning, innovation, and prototyping conversations</a:t>
-            </a:r>
-          </a:p>
-          <a:p>
-            <a:pPr>
-              <a:spcAft>
-                <a:spcPts val="1000"/>
-              </a:spcAft>
-              <a:defRPr sz="1600">
-                <a:solidFill>
-                  <a:srgbClr val="102A43"/>
-                </a:solidFill>
-                <a:latin typeface="Aptos"/>
-              </a:defRPr>
-            </a:pPr>
-            <a:r>
-              <a:t>Scenario workshops about distributed-campus routing and community diversion</a:t>
-            </a:r>
-          </a:p>
-          <a:p>
-            <a:pPr>
-              <a:spcAft>
-                <a:spcPts val="1000"/>
-              </a:spcAft>
-              <a:defRPr sz="1600">
-                <a:solidFill>
-                  <a:srgbClr val="102A43"/>
-                </a:solidFill>
-                <a:latin typeface="Aptos"/>
-              </a:defRPr>
-            </a:pPr>
-            <a:r>
-              <a:t>Testing dashboards, workflows, and early-stage analytics without real patient records</a:t>
-            </a:r>
-          </a:p>
-          <a:p>
-            <a:pPr>
-              <a:spcAft>
-                <a:spcPts val="1000"/>
-              </a:spcAft>
-              <a:defRPr sz="1600">
-                <a:solidFill>
-                  <a:srgbClr val="102A43"/>
-                </a:solidFill>
-                <a:latin typeface="Aptos"/>
-              </a:defRPr>
-            </a:pPr>
-            <a:r>
-              <a:t>Pitch-day storytelling backed by metrics, cautions, and exportable artifacts</a:t>
-            </a:r>
-          </a:p>
-        </p:txBody>
-      </p:sp>
-      <p:sp>
-        <p:nvSpPr>
-          <p:cNvPr id="9" name="Rounded Rectangle 8"/>
-          <p:cNvSpPr/>
-          <p:nvPr/>
-        </p:nvSpPr>
-        <p:spPr>
-          <a:xfrm>
-            <a:off x="6144768" y="1993392"/>
-            <a:ext cx="5468112" cy="4151376"/>
-          </a:xfrm>
-          <a:prstGeom prst="roundRect">
-            <a:avLst/>
-          </a:prstGeom>
-          <a:solidFill>
-            <a:srgbClr val="FFEFEA"/>
-          </a:solidFill>
-          <a:ln>
-            <a:noFill/>
-          </a:ln>
-        </p:spPr>
-        <p:style>
-          <a:lnRef idx="1">
-            <a:schemeClr val="accent1"/>
-          </a:lnRef>
-          <a:fillRef idx="3">
-            <a:schemeClr val="accent1"/>
-          </a:fillRef>
-          <a:effectRef idx="2">
-            <a:schemeClr val="accent1"/>
-          </a:effectRef>
-          <a:fontRef idx="minor">
-            <a:schemeClr val="lt1"/>
-          </a:fontRef>
-        </p:style>
-        <p:txBody>
-          <a:bodyPr rtlCol="0" anchor="ctr" wrap="square"/>
-          <a:lstStyle/>
-          <a:p>
-            <a:pPr algn="ctr"/>
-            <a:r>
-              <a:rPr sz="2400" b="1">
-                <a:solidFill>
-                  <a:srgbClr val="9A3412"/>
-                </a:solidFill>
-                <a:latin typeface="Aptos Display"/>
-              </a:rPr>
-              <a:t>Not Ready For</a:t>
-            </a:r>
-          </a:p>
-          <a:p>
-            <a:pPr>
-              <a:spcAft>
-                <a:spcPts val="1000"/>
-              </a:spcAft>
-              <a:defRPr sz="1600">
-                <a:solidFill>
-                  <a:srgbClr val="102A43"/>
-                </a:solidFill>
-                <a:latin typeface="Aptos"/>
-              </a:defRPr>
-            </a:pPr>
-            <a:r>
-              <a:t>Clinical care, staffing commitments, reimbursement, or patient-level action</a:t>
-            </a:r>
-          </a:p>
-          <a:p>
-            <a:pPr>
-              <a:spcAft>
-                <a:spcPts val="1000"/>
-              </a:spcAft>
-              <a:defRPr sz="1600">
-                <a:solidFill>
-                  <a:srgbClr val="102A43"/>
-                </a:solidFill>
-                <a:latin typeface="Aptos"/>
-              </a:defRPr>
-            </a:pPr>
-            <a:r>
-              <a:t>Claims about Southlake's real patient mix or operational truth from a U.S. public-use source</a:t>
-            </a:r>
-          </a:p>
-          <a:p>
-            <a:pPr>
-              <a:spcAft>
-                <a:spcPts val="1000"/>
-              </a:spcAft>
-              <a:defRPr sz="1600">
-                <a:solidFill>
-                  <a:srgbClr val="102A43"/>
-                </a:solidFill>
-                <a:latin typeface="Aptos"/>
-              </a:defRPr>
-            </a:pPr>
-            <a:r>
-              <a:t>A full hospital digital twin or a validated multi-table operational model</a:t>
-            </a:r>
-          </a:p>
-          <a:p>
-            <a:pPr>
-              <a:spcAft>
-                <a:spcPts val="1000"/>
-              </a:spcAft>
-              <a:defRPr sz="1600">
-                <a:solidFill>
-                  <a:srgbClr val="102A43"/>
-                </a:solidFill>
-                <a:latin typeface="Aptos"/>
-              </a:defRPr>
-            </a:pPr>
-            <a:r>
-              <a:t>Production use without governance, privacy review, and validation on governed local data</a:t>
-            </a:r>
-          </a:p>
-        </p:txBody>
-      </p:sp>
-      <p:sp>
-        <p:nvSpPr>
-          <p:cNvPr id="10" name="Rounded Rectangle 9"/>
-          <p:cNvSpPr/>
-          <p:nvPr/>
-        </p:nvSpPr>
-        <p:spPr>
-          <a:xfrm>
-            <a:off x="841248" y="5632704"/>
-            <a:ext cx="10607040" cy="530352"/>
-          </a:xfrm>
-          <a:prstGeom prst="roundRect">
-            <a:avLst/>
-          </a:prstGeom>
-          <a:solidFill>
-            <a:srgbClr val="1E293B"/>
-          </a:solidFill>
-          <a:ln>
-            <a:noFill/>
-          </a:ln>
-        </p:spPr>
-        <p:style>
-          <a:lnRef idx="1">
-            <a:schemeClr val="accent1"/>
-          </a:lnRef>
-          <a:fillRef idx="3">
-            <a:schemeClr val="accent1"/>
-          </a:fillRef>
-          <a:effectRef idx="2">
-            <a:schemeClr val="accent1"/>
-          </a:effectRef>
-          <a:fontRef idx="minor">
-            <a:schemeClr val="lt1"/>
-          </a:fontRef>
-        </p:style>
-        <p:txBody>
-          <a:bodyPr rtlCol="0" anchor="ctr"/>
-          <a:lstStyle/>
-          <a:p>
-            <a:pPr algn="ctr"/>
-            <a:r>
-              <a:rPr sz="1400" b="1">
-                <a:solidFill>
-                  <a:srgbClr val="FFFFFF"/>
-                </a:solidFill>
-                <a:latin typeface="Aptos"/>
-              </a:rPr>
-              <a:t>Best next step: validate the workflow with governed Southlake data, operational owners, and formal privacy review.</a:t>
-            </a:r>
-          </a:p>
-        </p:txBody>
-      </p:sp>
-      <p:sp>
-        <p:nvSpPr>
-          <p:cNvPr id="11" name="TextBox 10"/>
-          <p:cNvSpPr txBox="1"/>
-          <p:nvPr/>
-        </p:nvSpPr>
-        <p:spPr>
-          <a:xfrm>
-            <a:off x="658368" y="6419088"/>
-            <a:ext cx="8686800" cy="228600"/>
-          </a:xfrm>
-          <a:prstGeom prst="rect">
-            <a:avLst/>
-          </a:prstGeom>
-          <a:noFill/>
-        </p:spPr>
-        <p:txBody>
-          <a:bodyPr wrap="square" anchor="t">
-            <a:spAutoFit/>
-          </a:bodyPr>
-          <a:lstStyle/>
-          <a:p>
-            <a:pPr algn="l"/>
-            <a:r>
-              <a:rPr sz="1000" b="0">
-                <a:solidFill>
-                  <a:srgbClr val="5A7184"/>
-                </a:solidFill>
-                <a:latin typeface="Aptos"/>
-              </a:rPr>
-              <a:t>Credibility note: this caution slide is a strength. It shows the team understands healthcare risk and is not overselling the prototype.</a:t>
-            </a:r>
-          </a:p>
-        </p:txBody>
-      </p:sp>
+      </p:pic>
     </p:spTree>
   </p:cSld>
   <p:clrMapOvr>

</xml_diff>

<commit_message>
Save Keynote-edited deck (Haoran's final slide modifications)
</commit_message>
<xml_diff>
--- a/pitch/Southlake-Agentic-Synthetic-Data-Studio-Deck.pptx
+++ b/pitch/Southlake-Agentic-Synthetic-Data-Studio-Deck.pptx
@@ -4163,7 +4163,7 @@
         </p:nvSpPr>
         <p:spPr>
           <a:xfrm>
-            <a:off x="704088" y="384047"/>
+            <a:off x="665464" y="165181"/>
             <a:ext cx="4480561" cy="256541"/>
           </a:xfrm>
           <a:prstGeom prst="rect">
@@ -4469,7 +4469,7 @@
         </p:nvSpPr>
         <p:spPr>
           <a:xfrm>
-            <a:off x="7452360" y="1755648"/>
+            <a:off x="7503858" y="1311614"/>
             <a:ext cx="3474720" cy="269241"/>
           </a:xfrm>
           <a:prstGeom prst="rect">
@@ -4517,7 +4517,7 @@
         </p:nvSpPr>
         <p:spPr>
           <a:xfrm>
-            <a:off x="7768902" y="2068576"/>
+            <a:off x="7614407" y="1561762"/>
             <a:ext cx="3657601" cy="2755901"/>
           </a:xfrm>
           <a:prstGeom prst="rect">
@@ -4615,164 +4615,9 @@
           </a:p>
         </p:txBody>
       </p:sp>
-      <p:grpSp>
-        <p:nvGrpSpPr>
-          <p:cNvPr id="137" name="Rounded Rectangle 15"/>
-          <p:cNvGrpSpPr/>
-          <p:nvPr/>
-        </p:nvGrpSpPr>
-        <p:grpSpPr>
-          <a:xfrm>
-            <a:off x="7768902" y="4926838"/>
-            <a:ext cx="3657601" cy="1389889"/>
-            <a:chOff x="0" y="0"/>
-            <a:chExt cx="3657600" cy="1389888"/>
-          </a:xfrm>
-        </p:grpSpPr>
-        <p:sp>
-          <p:nvSpPr>
-            <p:cNvPr id="135" name="Rounded Rectangle"/>
-            <p:cNvSpPr/>
-            <p:nvPr/>
-          </p:nvSpPr>
-          <p:spPr>
-            <a:xfrm>
-              <a:off x="0" y="0"/>
-              <a:ext cx="3657600" cy="1389889"/>
-            </a:xfrm>
-            <a:prstGeom prst="roundRect">
-              <a:avLst>
-                <a:gd name="adj" fmla="val 16667"/>
-              </a:avLst>
-            </a:prstGeom>
-            <a:solidFill>
-              <a:srgbClr val="1E293B"/>
-            </a:solidFill>
-            <a:ln w="12700" cap="flat">
-              <a:noFill/>
-              <a:miter lim="400000"/>
-            </a:ln>
-            <a:effectLst>
-              <a:outerShdw sx="100000" sy="100000" kx="0" ky="0" algn="b" rotWithShape="0" blurRad="38100" dist="23000" dir="5400000">
-                <a:srgbClr val="000000">
-                  <a:alpha val="35000"/>
-                </a:srgbClr>
-              </a:outerShdw>
-            </a:effectLst>
-          </p:spPr>
-          <p:txBody>
-            <a:bodyPr wrap="square" lIns="45719" tIns="45719" rIns="45719" bIns="45719" numCol="1" anchor="t">
-              <a:noAutofit/>
-            </a:bodyPr>
-            <a:lstStyle/>
-            <a:p>
-              <a:pPr>
-                <a:defRPr sz="1300">
-                  <a:solidFill>
-                    <a:srgbClr val="FFFFFF"/>
-                  </a:solidFill>
-                  <a:latin typeface="Aptos"/>
-                  <a:ea typeface="Aptos"/>
-                  <a:cs typeface="Aptos"/>
-                  <a:sym typeface="Aptos"/>
-                </a:defRPr>
-              </a:pPr>
-            </a:p>
-          </p:txBody>
-        </p:sp>
-        <p:sp>
-          <p:nvSpPr>
-            <p:cNvPr id="136" name="Primary saved run…"/>
-            <p:cNvSpPr txBox="1"/>
-            <p:nvPr/>
-          </p:nvSpPr>
-          <p:spPr>
-            <a:xfrm>
-              <a:off x="113568" y="67848"/>
-              <a:ext cx="3430464" cy="1018541"/>
-            </a:xfrm>
-            <a:prstGeom prst="rect">
-              <a:avLst/>
-            </a:prstGeom>
-            <a:noFill/>
-            <a:ln w="12700" cap="flat">
-              <a:noFill/>
-              <a:miter lim="400000"/>
-            </a:ln>
-            <a:effectLst/>
-            <a:extLst>
-              <a:ext uri="{C572A759-6A51-4108-AA02-DFA0A04FC94B}">
-                <ma14:wrappingTextBoxFlag xmlns:ma14="http://schemas.microsoft.com/office/mac/drawingml/2011/main" val="1"/>
-              </a:ext>
-            </a:extLst>
-          </p:spPr>
-          <p:txBody>
-            <a:bodyPr wrap="square" lIns="45719" tIns="45719" rIns="45719" bIns="45719" numCol="1" anchor="t">
-              <a:spAutoFit/>
-            </a:bodyPr>
-            <a:lstStyle/>
-            <a:p>
-              <a:pPr algn="ctr">
-                <a:defRPr b="1" sz="1100">
-                  <a:solidFill>
-                    <a:srgbClr val="AEEFD7"/>
-                  </a:solidFill>
-                  <a:latin typeface="Aptos"/>
-                  <a:ea typeface="Aptos"/>
-                  <a:cs typeface="Aptos"/>
-                  <a:sym typeface="Aptos"/>
-                </a:defRPr>
-              </a:pPr>
-              <a:r>
-                <a:t>Primary saved run</a:t>
-              </a:r>
-              <a:endParaRPr>
-                <a:solidFill>
-                  <a:srgbClr val="FFFFFF"/>
-                </a:solidFill>
-              </a:endParaRPr>
-            </a:p>
-            <a:p>
-              <a:pPr>
-                <a:spcBef>
-                  <a:spcPts val="600"/>
-                </a:spcBef>
-                <a:defRPr b="1" sz="1600">
-                  <a:solidFill>
-                    <a:srgbClr val="FFFFFF"/>
-                  </a:solidFill>
-                  <a:latin typeface="Aptos"/>
-                  <a:ea typeface="Aptos"/>
-                  <a:cs typeface="Aptos"/>
-                  <a:sym typeface="Aptos"/>
-                </a:defRPr>
-              </a:pPr>
-              <a:r>
-                <a:t>Distributed Campus Routing | run f24271e772</a:t>
-              </a:r>
-            </a:p>
-            <a:p>
-              <a:pPr>
-                <a:defRPr sz="1300">
-                  <a:solidFill>
-                    <a:srgbClr val="FFFFFF"/>
-                  </a:solidFill>
-                  <a:latin typeface="Aptos"/>
-                  <a:ea typeface="Aptos"/>
-                  <a:cs typeface="Aptos"/>
-                  <a:sym typeface="Aptos"/>
-                </a:defRPr>
-              </a:pPr>
-              <a:r>
-                <a:t>Fidelity 87.8   Privacy 100.0   Utility 92.7</a:t>
-              </a:r>
-            </a:p>
-          </p:txBody>
-        </p:sp>
-      </p:grpSp>
       <p:sp>
         <p:nvSpPr>
-          <p:cNvPr id="138" name="TextBox 16"/>
+          <p:cNvPr id="135" name="TextBox 16"/>
           <p:cNvSpPr txBox="1"/>
           <p:nvPr/>
         </p:nvSpPr>
@@ -4820,13 +4665,13 @@
       </p:sp>
       <p:grpSp>
         <p:nvGrpSpPr>
-          <p:cNvPr id="141" name="Image Gallery"/>
+          <p:cNvPr id="138" name="Image Gallery"/>
           <p:cNvGrpSpPr/>
           <p:nvPr/>
         </p:nvGrpSpPr>
         <p:grpSpPr>
           <a:xfrm>
-            <a:off x="421132" y="1793969"/>
+            <a:off x="54443" y="1367454"/>
             <a:ext cx="6875272" cy="4332798"/>
             <a:chOff x="0" y="0"/>
             <a:chExt cx="6875271" cy="4332796"/>
@@ -4834,7 +4679,7 @@
         </p:grpSpPr>
         <p:pic>
           <p:nvPicPr>
-            <p:cNvPr id="139" name="Screenshot 2026-03-17 at 12.36.08 AM.png" descr="Screenshot 2026-03-17 at 12.36.08 AM.png"/>
+            <p:cNvPr id="136" name="Screenshot 2026-03-17 at 12.36.08 AM.png" descr="Screenshot 2026-03-17 at 12.36.08 AM.png"/>
             <p:cNvPicPr>
               <a:picLocks noChangeAspect="1"/>
             </p:cNvPicPr>
@@ -4866,7 +4711,7 @@
         </p:pic>
         <p:sp>
           <p:nvSpPr>
-            <p:cNvPr id="140" name="Caption"/>
+            <p:cNvPr id="137" name="Caption"/>
             <p:cNvSpPr/>
             <p:nvPr/>
           </p:nvSpPr>
@@ -4874,6 +4719,92 @@
             <a:xfrm>
               <a:off x="0" y="3938749"/>
               <a:ext cx="6875272" cy="394048"/>
+            </a:xfrm>
+            <a:prstGeom prst="rect">
+              <a:avLst/>
+            </a:prstGeom>
+            <a:noFill/>
+            <a:ln w="12700" cap="flat">
+              <a:noFill/>
+              <a:miter lim="400000"/>
+            </a:ln>
+            <a:effectLst/>
+            <a:extLst>
+              <a:ext uri="{C572A759-6A51-4108-AA02-DFA0A04FC94B}">
+                <ma14:wrappingTextBoxFlag xmlns:ma14="http://schemas.microsoft.com/office/mac/drawingml/2011/main" val="1"/>
+              </a:ext>
+            </a:extLst>
+          </p:spPr>
+          <p:txBody>
+            <a:bodyPr wrap="square" lIns="76200" tIns="76200" rIns="76200" bIns="76200" numCol="1" anchor="t">
+              <a:noAutofit/>
+            </a:bodyPr>
+            <a:lstStyle/>
+            <a:p>
+              <a:pPr/>
+              <a:r>
+                <a:t>Caption</a:t>
+              </a:r>
+            </a:p>
+          </p:txBody>
+        </p:sp>
+      </p:grpSp>
+      <p:grpSp>
+        <p:nvGrpSpPr>
+          <p:cNvPr id="141" name="Image Gallery"/>
+          <p:cNvGrpSpPr/>
+          <p:nvPr/>
+        </p:nvGrpSpPr>
+        <p:grpSpPr>
+          <a:xfrm>
+            <a:off x="6809849" y="4352548"/>
+            <a:ext cx="5175384" cy="2640504"/>
+            <a:chOff x="0" y="0"/>
+            <a:chExt cx="5175382" cy="2640502"/>
+          </a:xfrm>
+        </p:grpSpPr>
+        <p:pic>
+          <p:nvPicPr>
+            <p:cNvPr id="139" name="Screenshot 2026-03-17 at 1.10.10 AM.png" descr="Screenshot 2026-03-17 at 1.10.10 AM.png"/>
+            <p:cNvPicPr>
+              <a:picLocks noChangeAspect="1"/>
+            </p:cNvPicPr>
+            <p:nvPr/>
+          </p:nvPicPr>
+          <p:blipFill>
+            <a:blip r:embed="rId3">
+              <a:extLst/>
+            </a:blip>
+            <a:srcRect l="0" t="5310" r="0" b="5310"/>
+            <a:stretch>
+              <a:fillRect/>
+            </a:stretch>
+          </p:blipFill>
+          <p:spPr>
+            <a:xfrm>
+              <a:off x="0" y="0"/>
+              <a:ext cx="5175383" cy="2170256"/>
+            </a:xfrm>
+            <a:prstGeom prst="rect">
+              <a:avLst/>
+            </a:prstGeom>
+            <a:ln w="12700" cap="flat">
+              <a:noFill/>
+              <a:miter lim="400000"/>
+            </a:ln>
+            <a:effectLst/>
+          </p:spPr>
+        </p:pic>
+        <p:sp>
+          <p:nvSpPr>
+            <p:cNvPr id="140" name="Caption"/>
+            <p:cNvSpPr/>
+            <p:nvPr/>
+          </p:nvSpPr>
+          <p:spPr>
+            <a:xfrm>
+              <a:off x="0" y="2246455"/>
+              <a:ext cx="5175383" cy="394048"/>
             </a:xfrm>
             <a:prstGeom prst="rect">
               <a:avLst/>

</xml_diff>